<commit_message>
research(paper): sync deck with integrity finding #2 — pipeline honesty + confound caveat
Deck now matches the corrected paper: (1) arch-overview + dataset slides state
the interaction pipeline is used for VAE + pooled baseline while the main model
trains with uniform sampling/random windows; (2) main-result slide carries the
confound caveat with the in-flight 2x2 control; (3) limitations slide lists the
7-job hardening work in flight.
</commit_message>
<xml_diff>
--- a/research/to_human/EgoPed_professor_deck.pptx
+++ b/research/to_human/EgoPed_professor_deck.pptx
@@ -4840,6 +4840,22 @@
                 </a:solidFill>
                 <a:latin typeface="Calibri"/>
               </a:rPr>
+              <a:t>•  Hardening in flight (7 cluster jobs): seed-variance reruns, pipeline 2×2 control, random-init-encoder ablation; plus external baselines (regressor + raw-space diffusion) and a trajectory ADE/FDE metric.</a:t>
+            </a:r>
+          </a:p>
+          <a:p>
+            <a:pPr>
+              <a:spcAft>
+                <a:spcPts val="700"/>
+              </a:spcAft>
+            </a:pPr>
+            <a:r>
+              <a:rPr sz="1600" b="0" i="0">
+                <a:solidFill>
+                  <a:srgbClr val="1F2A37"/>
+                </a:solidFill>
+                <a:latin typeface="Calibri"/>
+              </a:rPr>
               <a:t>•  Status: main results, three ablations, and held-out validation complete; paper draft in progress.</a:t>
             </a:r>
           </a:p>
@@ -6438,7 +6454,7 @@
                 </a:solidFill>
                 <a:latin typeface="Calibri"/>
               </a:rPr>
-              <a:t> interaction-aware data pipeline: interaction scoring, weighted oversampling, and closest-approach 196-frame cropping.</a:t>
+              <a:t> interaction-aware data pipeline (scoring, weighted oversampling, closest-approach crops) — used for VAE + pooled-baseline training; the main model trains with uniform sampling (isolation ablation in progress).</a:t>
             </a:r>
           </a:p>
           <a:p>
@@ -6677,7 +6693,7 @@
                 </a:solidFill>
                 <a:latin typeface="Calibri"/>
               </a:rPr>
-              <a:t>•  Interaction-aware: score = travel × (%frames within 5 m) × relative-bearing change → weighted sampling + closest-approach 196-frame crop.</a:t>
+              <a:t>•  Interaction-aware processing: score = travel × (%frames within 5 m) × relative-bearing change → weighted sampling + closest-approach crop (used for VAE + pooled baseline; main model: uniform sampling, random windows).</a:t>
             </a:r>
           </a:p>
           <a:p>
@@ -7923,6 +7939,40 @@
           </a:p>
         </p:txBody>
       </p:sp>
+      <p:sp>
+        <p:nvSpPr>
+          <p:cNvPr id="7" name="TextBox 6"/>
+          <p:cNvSpPr txBox="1"/>
+          <p:nvPr/>
+        </p:nvSpPr>
+        <p:spPr>
+          <a:xfrm>
+            <a:off x="548640" y="5989320"/>
+            <a:ext cx="11064240" cy="457200"/>
+          </a:xfrm>
+          <a:prstGeom prst="rect">
+            <a:avLst/>
+          </a:prstGeom>
+          <a:noFill/>
+        </p:spPr>
+        <p:txBody>
+          <a:bodyPr wrap="square" anchor="t">
+            <a:spAutoFit/>
+          </a:bodyPr>
+          <a:lstStyle/>
+          <a:p>
+            <a:r>
+              <a:rPr sz="1100" b="0" i="1">
+                <a:solidFill>
+                  <a:srgbClr val="5B6672"/>
+                </a:solidFill>
+                <a:latin typeface="Calibri"/>
+              </a:rPr>
+              <a:t>Caveat (in progress): the baseline additionally trained with the interaction-weighted pipeline; matched-pipeline 2×2 control runs are on the cluster to isolate the pure conditioning effect.</a:t>
+            </a:r>
+          </a:p>
+        </p:txBody>
+      </p:sp>
     </p:spTree>
   </p:cSld>
   <p:clrMapOvr>

</xml_diff>

<commit_message>
research(paper): deck refreshed to match the rewrite — unified 40%, EgoPed-IA row, hardening verdicts
Main-result slide: unified table + EgoPed-IA (2.880), conservative-verified
framing replaces the in-progress caveat; ablation-1 unified numbers (6.677 vs
5.620); recipe + limitations slides now carry the full hardening verdicts
(2x2, seeds, rand-init, ADE/FDE, behavioral probe, baseline ladder).
</commit_message>
<xml_diff>
--- a/research/to_human/EgoPed_professor_deck.pptx
+++ b/research/to_human/EgoPed_professor_deck.pptx
@@ -4297,7 +4297,7 @@
                 </a:solidFill>
                 <a:latin typeface="Calibri"/>
               </a:rPr>
-              <a:t>•  Full-sequence temporal conditioning beats single-token pooled conditioning by 49% FID — robust to CFG and to the attention mechanism.</a:t>
+              <a:t>•  Full-sequence temporal conditioning beats pooled by 40% FID (unified eval, verified conservative) — robust to CFG and attention mechanism; interaction-aware sampling amplifies it to FID 2.88 (EgoPed-IA).</a:t>
             </a:r>
           </a:p>
           <a:p>
@@ -4840,7 +4840,39 @@
                 </a:solidFill>
                 <a:latin typeface="Calibri"/>
               </a:rPr>
-              <a:t>•  Hardening in flight (7 cluster jobs): seed-variance reruns, pipeline 2×2 control, random-init-encoder ablation; plus external baselines (regressor + raw-space diffusion) and a trajectory ADE/FDE metric.</a:t>
+              <a:t>•  Hardening complete: pipeline 2×2 (granularity dominates; sampling amplifies), seed spread reported (3.39/4.72/4.80 — best-seed stated), random-init encoder = unconditional (pretraining essential).</a:t>
+            </a:r>
+          </a:p>
+          <a:p>
+            <a:pPr>
+              <a:spcAft>
+                <a:spcPts val="700"/>
+              </a:spcAft>
+            </a:pPr>
+            <a:r>
+              <a:rPr sz="1600" b="0" i="0">
+                <a:solidFill>
+                  <a:srgbClr val="1F2A37"/>
+                </a:solidFill>
+                <a:latin typeface="Calibri"/>
+              </a:rPr>
+              <a:t>•  Three evaluator-independent validations: held-out split (ranking preserved), trajectory ADE/FDE (H4 beats pooled on all 4), behavioral probe (H4 couples stop/walk decisions to ego best; collapsed H6 overcommits).</a:t>
+            </a:r>
+          </a:p>
+          <a:p>
+            <a:pPr>
+              <a:spcAft>
+                <a:spcPts val="700"/>
+              </a:spcAft>
+            </a:pPr>
+            <a:r>
+              <a:rPr sz="1600" b="0" i="0">
+                <a:solidFill>
+                  <a:srgbClr val="1F2A37"/>
+                </a:solidFill>
+                <a:latin typeface="Calibri"/>
+              </a:rPr>
+              <a:t>•  External baselines: raw-space diffusion 26.4, deterministic regressor 36 (L2-optimal yet unrealistic; EgoPed minADE-5 beats it WITH realism).</a:t>
             </a:r>
           </a:p>
           <a:p>
@@ -6429,7 +6461,7 @@
                 </a:solidFill>
                 <a:latin typeface="Calibri"/>
               </a:rPr>
-              <a:t> conditioning granularity: the denoiser sees all 196 per-timestep ego tokens (vs. a single pooled token) — the source of the 49% FID gain.</a:t>
+              <a:t> conditioning granularity: the denoiser sees all 196 per-timestep ego tokens (vs. a single pooled token) — the source of the 40% FID gain (unified evaluation, verified conservative).</a:t>
             </a:r>
           </a:p>
           <a:p>
@@ -7355,7 +7387,7 @@
                 </a:solidFill>
                 <a:latin typeface="Calibri"/>
               </a:rPr>
-              <a:t>−49% FID VS POOLED BASELINE</a:t>
+              <a:t>−40% FID (UNIFIED EVAL) · BEST SYSTEM EGOPED-IA 2.88</a:t>
             </a:r>
           </a:p>
           <a:p>
@@ -7381,7 +7413,7 @@
         </p:nvGraphicFramePr>
         <p:xfrm>
           <a:off x="640080" y="1463040"/>
-          <a:ext cx="10881358" cy="1536192"/>
+          <a:ext cx="10881358" cy="1920240"/>
         </p:xfrm>
         <a:graphic>
           <a:graphicData uri="http://schemas.openxmlformats.org/drawingml/2006/table">
@@ -7550,7 +7582,7 @@
                           </a:solidFill>
                           <a:latin typeface="Calibri"/>
                         </a:rPr>
-                        <a:t>6.603 ± 0.067</a:t>
+                        <a:t>5.620 ± 0.117</a:t>
                       </a:r>
                     </a:p>
                   </a:txBody>
@@ -7573,7 +7605,7 @@
                           </a:solidFill>
                           <a:latin typeface="Calibri"/>
                         </a:rPr>
-                        <a:t>0.671</a:t>
+                        <a:t>0.665</a:t>
                       </a:r>
                     </a:p>
                   </a:txBody>
@@ -7596,7 +7628,7 @@
                           </a:solidFill>
                           <a:latin typeface="Calibri"/>
                         </a:rPr>
-                        <a:t>3.50</a:t>
+                        <a:t>3.71</a:t>
                       </a:r>
                     </a:p>
                   </a:txBody>
@@ -7619,7 +7651,7 @@
                           </a:solidFill>
                           <a:latin typeface="Calibri"/>
                         </a:rPr>
-                        <a:t>5.78</a:t>
+                        <a:t>5.82</a:t>
                       </a:r>
                     </a:p>
                   </a:txBody>
@@ -7761,7 +7793,7 @@
                           </a:solidFill>
                           <a:latin typeface="Calibri"/>
                         </a:rPr>
-                        <a:t>Ground truth (reference)</a:t>
+                        <a:t>EgoPed-IA (+ interaction sampling)</a:t>
                       </a:r>
                     </a:p>
                   </a:txBody>
@@ -7784,7 +7816,7 @@
                           </a:solidFill>
                           <a:latin typeface="Calibri"/>
                         </a:rPr>
-                        <a:t>—</a:t>
+                        <a:t>2.880 ± 0.084</a:t>
                       </a:r>
                     </a:p>
                   </a:txBody>
@@ -7807,7 +7839,7 @@
                           </a:solidFill>
                           <a:latin typeface="Calibri"/>
                         </a:rPr>
-                        <a:t>—</a:t>
+                        <a:t>0.323</a:t>
                       </a:r>
                     </a:p>
                   </a:txBody>
@@ -7830,7 +7862,7 @@
                           </a:solidFill>
                           <a:latin typeface="Calibri"/>
                         </a:rPr>
-                        <a:t>—</a:t>
+                        <a:t>3.37</a:t>
                       </a:r>
                     </a:p>
                   </a:txBody>
@@ -7853,7 +7885,7 @@
                           </a:solidFill>
                           <a:latin typeface="Calibri"/>
                         </a:rPr>
-                        <a:t>5.50</a:t>
+                        <a:t>5.67</a:t>
                       </a:r>
                     </a:p>
                   </a:txBody>
@@ -7864,6 +7896,123 @@
                   </a:tcPr>
                 </a:tc>
               </a:tr>
+              <a:tr h="384048">
+                <a:tc>
+                  <a:txBody>
+                    <a:bodyPr wrap="square"/>
+                    <a:lstStyle/>
+                    <a:p>
+                      <a:pPr algn="l"/>
+                      <a:r>
+                        <a:rPr sz="1500" b="0" i="0">
+                          <a:solidFill>
+                            <a:srgbClr val="1F2A37"/>
+                          </a:solidFill>
+                          <a:latin typeface="Calibri"/>
+                        </a:rPr>
+                        <a:t>Ground truth (reference)</a:t>
+                      </a:r>
+                    </a:p>
+                  </a:txBody>
+                  <a:tcPr marT="25400" marB="25400" marL="88900">
+                    <a:solidFill>
+                      <a:srgbClr val="FFFFFF"/>
+                    </a:solidFill>
+                  </a:tcPr>
+                </a:tc>
+                <a:tc>
+                  <a:txBody>
+                    <a:bodyPr wrap="square"/>
+                    <a:lstStyle/>
+                    <a:p>
+                      <a:pPr algn="ctr"/>
+                      <a:r>
+                        <a:rPr sz="1500" b="0" i="0">
+                          <a:solidFill>
+                            <a:srgbClr val="1F2A37"/>
+                          </a:solidFill>
+                          <a:latin typeface="Calibri"/>
+                        </a:rPr>
+                        <a:t>—</a:t>
+                      </a:r>
+                    </a:p>
+                  </a:txBody>
+                  <a:tcPr marT="25400" marB="25400" marL="88900">
+                    <a:solidFill>
+                      <a:srgbClr val="FFFFFF"/>
+                    </a:solidFill>
+                  </a:tcPr>
+                </a:tc>
+                <a:tc>
+                  <a:txBody>
+                    <a:bodyPr wrap="square"/>
+                    <a:lstStyle/>
+                    <a:p>
+                      <a:pPr algn="ctr"/>
+                      <a:r>
+                        <a:rPr sz="1500" b="0" i="0">
+                          <a:solidFill>
+                            <a:srgbClr val="1F2A37"/>
+                          </a:solidFill>
+                          <a:latin typeface="Calibri"/>
+                        </a:rPr>
+                        <a:t>—</a:t>
+                      </a:r>
+                    </a:p>
+                  </a:txBody>
+                  <a:tcPr marT="25400" marB="25400" marL="88900">
+                    <a:solidFill>
+                      <a:srgbClr val="FFFFFF"/>
+                    </a:solidFill>
+                  </a:tcPr>
+                </a:tc>
+                <a:tc>
+                  <a:txBody>
+                    <a:bodyPr wrap="square"/>
+                    <a:lstStyle/>
+                    <a:p>
+                      <a:pPr algn="ctr"/>
+                      <a:r>
+                        <a:rPr sz="1500" b="0" i="0">
+                          <a:solidFill>
+                            <a:srgbClr val="1F2A37"/>
+                          </a:solidFill>
+                          <a:latin typeface="Calibri"/>
+                        </a:rPr>
+                        <a:t>—</a:t>
+                      </a:r>
+                    </a:p>
+                  </a:txBody>
+                  <a:tcPr marT="25400" marB="25400" marL="88900">
+                    <a:solidFill>
+                      <a:srgbClr val="FFFFFF"/>
+                    </a:solidFill>
+                  </a:tcPr>
+                </a:tc>
+                <a:tc>
+                  <a:txBody>
+                    <a:bodyPr wrap="square"/>
+                    <a:lstStyle/>
+                    <a:p>
+                      <a:pPr algn="ctr"/>
+                      <a:r>
+                        <a:rPr sz="1500" b="0" i="0">
+                          <a:solidFill>
+                            <a:srgbClr val="1F2A37"/>
+                          </a:solidFill>
+                          <a:latin typeface="Calibri"/>
+                        </a:rPr>
+                        <a:t>5.50</a:t>
+                      </a:r>
+                    </a:p>
+                  </a:txBody>
+                  <a:tcPr marT="25400" marB="25400" marL="88900">
+                    <a:solidFill>
+                      <a:srgbClr val="FFFFFF"/>
+                    </a:solidFill>
+                  </a:tcPr>
+                </a:tc>
+              </a:tr>
             </a:tbl>
           </a:graphicData>
         </a:graphic>
@@ -7902,7 +8051,7 @@
                 </a:solidFill>
                 <a:latin typeface="Calibri"/>
               </a:rPr>
-              <a:t>•  49% FID improvement over the strongest pooled baseline — confidence intervals are NON-OVERLAPPING (significant).</a:t>
+              <a:t>•  40% FID improvement under a UNIFIED evaluation pipeline (all models, identical eval-time processing) — non-overlapping CIs; verified conservative (pipeline handicap + baseline best-seed).</a:t>
             </a:r>
           </a:p>
           <a:p>
@@ -7968,7 +8117,7 @@
                 </a:solidFill>
                 <a:latin typeface="Calibri"/>
               </a:rPr>
-              <a:t>Caveat (in progress): the baseline additionally trained with the interaction-weighted pipeline; matched-pipeline 2×2 control runs are on the cluster to isolate the pure conditioning effect.</a:t>
+              <a:t>2×2 control complete: interaction-aware sampling amplifies the full-sequence model (3.39 → 2.88) and barely moves the pooled baseline — the headline is conservative. EgoPed-IA is single-seed (stated).</a:t>
             </a:r>
           </a:p>
         </p:txBody>
@@ -8707,7 +8856,7 @@
                 </a:solidFill>
                 <a:latin typeface="Calibri"/>
               </a:rPr>
-              <a:t>•  Result: latent-8 is 14.5% WORSE FID (7.563 vs 6.603) at matched epoch &amp; CFG; R-Precision essentially unchanged (0.676 vs 0.671).</a:t>
+              <a:t>•  Result: latent-8 is 19% WORSE FID (6.677 vs 5.620, unified eval) at matched epoch &amp; CFG; R-Precision essentially unchanged (0.663 vs 0.665).</a:t>
             </a:r>
           </a:p>
           <a:p>

</xml_diff>

<commit_message>
research(results): 2x2 COMPLETE — H2-nopipe definitive 6.214±0.105; gains additive; arc closed
All four cells definitive. Granularity dominates (~2.7-2.8 both columns, ~5x
the pipeline effect); pipeline gains additive and similar for both archs
(-0.59/-0.51) — corrected the earlier 'barely moves pooled' claim (was based
on training-time val). Paper tab:pipeline2x2 finalized (asterisk dropped),
deck updated, compiles clean. Agent-side review items all closed.
</commit_message>
<xml_diff>
--- a/research/to_human/EgoPed_professor_deck.pptx
+++ b/research/to_human/EgoPed_professor_deck.pptx
@@ -4840,7 +4840,7 @@
                 </a:solidFill>
                 <a:latin typeface="Calibri"/>
               </a:rPr>
-              <a:t>•  Hardening complete: pipeline 2×2 (granularity dominates; sampling amplifies), seed spread reported (3.39/4.72/4.80 — best-seed stated), random-init encoder = unconditional (pretraining essential).</a:t>
+              <a:t>•  Hardening complete: pipeline 2×2 (granularity dominates ~5×; sampling additive ~0.5 FID both), seed spread reported (3.39/4.72/4.80 — best-seed stated), random-init encoder = unconditional (pretraining essential).</a:t>
             </a:r>
           </a:p>
           <a:p>
@@ -8117,7 +8117,7 @@
                 </a:solidFill>
                 <a:latin typeface="Calibri"/>
               </a:rPr>
-              <a:t>2×2 control complete: interaction-aware sampling amplifies the full-sequence model (3.39 → 2.88) and barely moves the pooled baseline — the headline is conservative. EgoPed-IA is single-seed (stated).</a:t>
+              <a:t>2×2 control complete (definitive): granularity dominates (~2.7 FID in both columns); interaction-aware sampling adds ~0.5-0.6 to BOTH architectures (additive). EgoPed-IA is single-seed (stated).</a:t>
             </a:r>
           </a:p>
         </p:txBody>

</xml_diff>